<commit_message>
Endereco do TAG por terminal, merged hex por sysbuild e hex regerados
- 02/03/05 CS initiators e 03_central_uart pedem o endereco do TAG na
  serial no boot (lab_tag_addr.c/h); removidos meu_tag.conf e a ponte
  binaria (binary_bridge.conf, hex 03_central_uart_binario)
- sysbuild.conf com SB_CONFIG_MERGED_HEX_FILES=y em todos os labs
  (comms, edge_ai, gnss, ntn); build_all.py de comms/edge_ai/gnss
  procuram merged_<board>.hex
- hex de comms/ e edge_ai/ regerados; 05_data_forwarder unificado em
  um unico hex (removidos _4g e _sample)
- 05_data_forwarder: datasets de coleta e gestos centrados, ferramentas
  loop1_para_host.py e test_center_host.py, ajustes no bmi270
- READMEs de comms, hex e edge_ai atualizados; decks M1-04/05/06

Co-Authored-By: Claude Fable 5.1 <noreply@anthropic.com>
Claude-Session: https://claude.ai/code/session_01X4jFwH89svuJh2FZLsSprA
</commit_message>
<xml_diff>
--- a/edge_ai/pptx/M1-04_Loop1_Modelo_Proprio.pptx
+++ b/edge_ai/pptx/M1-04_Loop1_Modelo_Proprio.pptx
@@ -12227,7 +12227,7 @@
                 </a:solidFill>
                 <a:latin typeface="Segoe UI"/>
               </a:rPr>
-              <a:t>nRF54LM20-DK filtra</a:t>
+              <a:t>nRF54LM20-DK pergunta</a:t>
             </a:r>
           </a:p>
           <a:p>
@@ -12243,7 +12243,7 @@
                 </a:solidFill>
                 <a:latin typeface="Segoe UI"/>
               </a:rPr>
-              <a:t>pelo SEU endereço</a:t>
+              <a:t>o endereço no boot</a:t>
             </a:r>
           </a:p>
         </p:txBody>
@@ -20983,7 +20983,7 @@
                 </a:solidFill>
                 <a:latin typeface="Segoe UI"/>
               </a:rPr>
-              <a:t>Filtra pelo endereço da </a:t>
+              <a:t>Pede o endereço da </a:t>
             </a:r>
             <a:r>
               <a:rPr sz="1200" b="1" i="0">
@@ -21001,7 +21001,7 @@
                 </a:solidFill>
                 <a:latin typeface="Segoe UI"/>
               </a:rPr>
-              <a:t> TAG — só ela conecta</a:t>
+              <a:t> TAG no terminal e só conecta nela</a:t>
             </a:r>
           </a:p>
           <a:p>
@@ -24625,7 +24625,7 @@
                 </a:solidFill>
                 <a:latin typeface="Segoe UI"/>
               </a:rPr>
-              <a:t>Copie VALUE e TYPE: os dois entram no meu_tag.conf.</a:t>
+              <a:t>Anote VALUE e TYPE: é o que você digita no prompt do central.</a:t>
             </a:r>
           </a:p>
         </p:txBody>
@@ -24673,25 +24673,7 @@
                 </a:solidFill>
                 <a:latin typeface="Segoe UI"/>
               </a:rPr>
-              <a:t>Você já viu essa linha no bloco 03, ao programar a TAG — é o endereço que vai no </a:t>
-            </a:r>
-            <a:r>
-              <a:rPr sz="1400" b="0">
-                <a:solidFill>
-                  <a:srgbClr val="0B1B2B"/>
-                </a:solidFill>
-                <a:latin typeface="Consolas"/>
-              </a:rPr>
-              <a:t>meu_tag.conf</a:t>
-            </a:r>
-            <a:r>
-              <a:rPr sz="1400" b="0">
-                <a:solidFill>
-                  <a:srgbClr val="0B1B2B"/>
-                </a:solidFill>
-                <a:latin typeface="Segoe UI"/>
-              </a:rPr>
-              <a:t> do central</a:t>
+              <a:t>Você já viu essa linha no bloco 03, ao programar a TAG — é o endereço que o central vai pedir no terminal</a:t>
             </a:r>
           </a:p>
           <a:p>
@@ -24892,7 +24874,7 @@
                 </a:solidFill>
                 <a:latin typeface="Segoe UI"/>
               </a:rPr>
-              <a:t>O central filtra pelo seu endereço — ou não compila</a:t>
+              <a:t>O central pergunta o endereço no boot</a:t>
             </a:r>
           </a:p>
         </p:txBody>
@@ -25106,11 +25088,11 @@
             <a:r>
               <a:rPr sz="1400" b="0">
                 <a:solidFill>
-                  <a:srgbClr val="7FB58E"/>
+                  <a:srgbClr val="DCE8F2"/>
                 </a:solidFill>
                 <a:latin typeface="Consolas"/>
               </a:rPr>
-              <a:t># 03_central_uart/meu_tag.conf</a:t>
+              <a:t>Endereco BLE do tag (ex.: EC:EF:40:2D:5E:46 random): EC:EF:40:2D:5E:46 random</a:t>
             </a:r>
           </a:p>
           <a:p>
@@ -25126,77 +25108,23 @@
                 </a:solidFill>
                 <a:latin typeface="Consolas"/>
               </a:rPr>
-              <a:t>CONFIG_LAB_TAG_ADDR_VALUE=</a:t>
-            </a:r>
+              <a:t>Procurando o tag EC:EF:40:2D:5E:46 (random)...</a:t>
+            </a:r>
+          </a:p>
+          <a:p>
+            <a:pPr>
+              <a:lnSpc>
+                <a:spcPct val="112000"/>
+              </a:lnSpc>
+            </a:pPr>
             <a:r>
               <a:rPr sz="1400" b="0">
                 <a:solidFill>
-                  <a:srgbClr val="FFCF6B"/>
+                  <a:srgbClr val="DCE8F2"/>
                 </a:solidFill>
                 <a:latin typeface="Consolas"/>
               </a:rPr>
-              <a:t>"EC:EF:40:2D:5E:46"</a:t>
-            </a:r>
-            <a:r>
-              <a:rPr sz="1400" b="0">
-                <a:solidFill>
-                  <a:srgbClr val="DCE8F2"/>
-                </a:solidFill>
-                <a:latin typeface="Consolas"/>
-              </a:rPr>
-              <a:t>   </a:t>
-            </a:r>
-            <a:r>
-              <a:rPr sz="1400" b="0">
-                <a:solidFill>
-                  <a:srgbClr val="7FB58E"/>
-                </a:solidFill>
-                <a:latin typeface="Consolas"/>
-              </a:rPr>
-              <a:t># VALUE da linha Identity:</a:t>
-            </a:r>
-          </a:p>
-          <a:p>
-            <a:pPr>
-              <a:lnSpc>
-                <a:spcPct val="112000"/>
-              </a:lnSpc>
-            </a:pPr>
-            <a:r>
-              <a:rPr sz="1400" b="0">
-                <a:solidFill>
-                  <a:srgbClr val="DCE8F2"/>
-                </a:solidFill>
-                <a:latin typeface="Consolas"/>
-              </a:rPr>
-              <a:t>CONFIG_LAB_TAG_ADDR_TYPE=</a:t>
-            </a:r>
-            <a:r>
-              <a:rPr sz="1400" b="0">
-                <a:solidFill>
-                  <a:srgbClr val="FFCF6B"/>
-                </a:solidFill>
-                <a:latin typeface="Consolas"/>
-              </a:rPr>
-              <a:t>"random"</a:t>
-            </a:r>
-            <a:r>
-              <a:rPr sz="1400" b="0">
-                <a:solidFill>
-                  <a:srgbClr val="DCE8F2"/>
-                </a:solidFill>
-                <a:latin typeface="Consolas"/>
-              </a:rPr>
-              <a:t>               </a:t>
-            </a:r>
-            <a:r>
-              <a:rPr sz="1400" b="0">
-                <a:solidFill>
-                  <a:srgbClr val="7FB58E"/>
-                </a:solidFill>
-                <a:latin typeface="Consolas"/>
-              </a:rPr>
-              <a:t># TYPE</a:t>
+              <a:t>87799 67,9602,535,1,-3,0</a:t>
             </a:r>
           </a:p>
         </p:txBody>
@@ -25235,7 +25163,7 @@
                 </a:solidFill>
                 <a:latin typeface="Segoe UI"/>
               </a:rPr>
-              <a:t>O </a:t>
+              <a:t>Depois do </a:t>
             </a:r>
             <a:r>
               <a:rPr sz="1200" b="0" i="1">
@@ -25244,7 +25172,7 @@
                 </a:solidFill>
                 <a:latin typeface="Consolas"/>
               </a:rPr>
-              <a:t>pairing failed (peer reason 0x3)</a:t>
+              <a:t>Procurando</a:t>
             </a:r>
             <a:r>
               <a:rPr sz="1200" b="0" i="1">
@@ -25253,7 +25181,7 @@
                 </a:solidFill>
                 <a:latin typeface="Segoe UI"/>
               </a:rPr>
-              <a:t> que aparece em toda conexão é ruído: o dado flui.</a:t>
+              <a:t>, a serial só carrega o CSV da TAG — nada mais sai do central.</a:t>
             </a:r>
           </a:p>
         </p:txBody>
@@ -25301,7 +25229,7 @@
                 </a:solidFill>
                 <a:latin typeface="Segoe UI"/>
               </a:rPr>
-              <a:t>Build da nRF54LM20-DK com o </a:t>
+              <a:t>Grave a nRF54LM20-DK com o </a:t>
             </a:r>
             <a:r>
               <a:rPr sz="1400" b="0">
@@ -25319,34 +25247,25 @@
                 </a:solidFill>
                 <a:latin typeface="Segoe UI"/>
               </a:rPr>
-              <a:t> e </a:t>
+              <a:t> (sem fragmento) e abra a serial USB, </a:t>
+            </a:r>
+            <a:r>
+              <a:rPr sz="1400" b="1">
+                <a:solidFill>
+                  <a:srgbClr val="0093D0"/>
+                </a:solidFill>
+                <a:latin typeface="Segoe UI"/>
+              </a:rPr>
+              <a:t>115200 8N1</a:t>
             </a:r>
             <a:r>
               <a:rPr sz="1400" b="0">
                 <a:solidFill>
                   <a:srgbClr val="0B1B2B"/>
                 </a:solidFill>
-                <a:latin typeface="Consolas"/>
-              </a:rPr>
-              <a:t>meu_tag.conf</a:t>
-            </a:r>
-            <a:r>
-              <a:rPr sz="1400" b="0">
-                <a:solidFill>
-                  <a:srgbClr val="0B1B2B"/>
-                </a:solidFill>
-                <a:latin typeface="Segoe UI"/>
-              </a:rPr>
-              <a:t> em </a:t>
-            </a:r>
-            <a:r>
-              <a:rPr sz="1400" b="1">
-                <a:solidFill>
-                  <a:srgbClr val="0093D0"/>
-                </a:solidFill>
-                <a:latin typeface="Segoe UI"/>
-              </a:rPr>
-              <a:t>Kconfig fragments</a:t>
+                <a:latin typeface="Segoe UI"/>
+              </a:rPr>
+              <a:t>: o prompt repete a cada 5 s até você responder</a:t>
             </a:r>
           </a:p>
           <a:p>
@@ -25371,7 +25290,7 @@
                 </a:solidFill>
                 <a:latin typeface="Segoe UI"/>
               </a:rPr>
-              <a:t>Divergência do sample: o upstream filtra por UUID da NUS e conecta em qualquer tag. Aqui o filtro é o endereço, com </a:t>
+              <a:t>Divergência do sample: o upstream filtra por UUID da NUS e conecta em qualquer tag. Aqui o filtro é o endereço digitado, com </a:t>
             </a:r>
             <a:r>
               <a:rPr sz="1400" b="0">
@@ -25405,25 +25324,7 @@
                 </a:solidFill>
                 <a:latin typeface="Segoe UI"/>
               </a:rPr>
-              <a:t>Endereço vazio </a:t>
-            </a:r>
-            <a:r>
-              <a:rPr sz="1400" b="1">
-                <a:solidFill>
-                  <a:srgbClr val="0093D0"/>
-                </a:solidFill>
-                <a:latin typeface="Segoe UI"/>
-              </a:rPr>
-              <a:t>falha o build de propósito</a:t>
-            </a:r>
-            <a:r>
-              <a:rPr sz="1400" b="0">
-                <a:solidFill>
-                  <a:srgbClr val="0B1B2B"/>
-                </a:solidFill>
-                <a:latin typeface="Segoe UI"/>
-              </a:rPr>
-              <a:t> — um central sem filtro conectaria no tag do colega</a:t>
+              <a:t>Endereço inválido é recusado e o prompt volta; não existe valor padrão — um central sem filtro conectaria no tag do colega</a:t>
             </a:r>
           </a:p>
           <a:p>

</xml_diff>